<commit_message>
SIH deck: team CodeVerse, ID 133847
Co-Authored-By: Claude Sonnet 5.5 <noreply@anthropic.com>
</commit_message>
<xml_diff>
--- a/docs/SIH2026-Idea-Presentation.pptx
+++ b/docs/SIH2026-Idea-Presentation.pptx
@@ -5785,7 +5785,7 @@
                 </a:solidFill>
                 <a:latin typeface="Arial"/>
               </a:rPr>
-              <a:t>&lt;Team ID&gt;</a:t>
+              <a:t>133847</a:t>
             </a:r>
           </a:p>
           <a:p>
@@ -5813,7 +5813,7 @@
                 </a:solidFill>
                 <a:latin typeface="Arial"/>
               </a:rPr>
-              <a:t>Your Team Name</a:t>
+              <a:t>CodeVerse</a:t>
             </a:r>
             <a:endParaRPr lang="en-IN" sz="2400" b="1" dirty="0">
               <a:latin typeface="Arial" panose="020B0604020202020204" pitchFamily="34" charset="0"/>
@@ -6098,7 +6098,7 @@
             <a:pPr algn="ctr"/>
             <a:r>
               <a:rPr lang="en-US" dirty="0" sz="1100"/>
-              <a:t>Your Team Name</a:t>
+              <a:t>CodeVerse</a:t>
             </a:r>
             <a:endParaRPr lang="en-IN" dirty="0"/>
           </a:p>
@@ -7633,7 +7633,7 @@
             <a:pPr algn="ctr"/>
             <a:r>
               <a:rPr lang="en-US" dirty="0" sz="1100"/>
-              <a:t>Your Team Name</a:t>
+              <a:t>CodeVerse</a:t>
             </a:r>
             <a:endParaRPr lang="en-IN" dirty="0"/>
           </a:p>
@@ -9761,7 +9761,7 @@
             <a:pPr algn="ctr"/>
             <a:r>
               <a:rPr lang="en-US" dirty="0" sz="1100"/>
-              <a:t>Your Team Name</a:t>
+              <a:t>CodeVerse</a:t>
             </a:r>
             <a:endParaRPr lang="en-IN" dirty="0"/>
           </a:p>
@@ -11944,7 +11944,7 @@
             <a:pPr algn="ctr"/>
             <a:r>
               <a:rPr lang="en-US" dirty="0" sz="1100"/>
-              <a:t>Your Team Name</a:t>
+              <a:t>CodeVerse</a:t>
             </a:r>
             <a:endParaRPr lang="en-IN" dirty="0"/>
           </a:p>
@@ -14259,7 +14259,7 @@
             <a:pPr algn="ctr"/>
             <a:r>
               <a:rPr lang="en-US" dirty="0" sz="1100"/>
-              <a:t>Your Team Name</a:t>
+              <a:t>CodeVerse</a:t>
             </a:r>
             <a:endParaRPr lang="en-IN" dirty="0"/>
           </a:p>

</xml_diff>

<commit_message>
SIH deck: explain AI and cloud usage on the technical approach slide
Co-Authored-By: Claude Sonnet 5.5 <noreply@anthropic.com>
</commit_message>
<xml_diff>
--- a/docs/SIH2026-Idea-Presentation.pptx
+++ b/docs/SIH2026-Idea-Presentation.pptx
@@ -8294,35 +8294,59 @@
           </a:graphicData>
         </a:graphic>
       </p:graphicFrame>
-      <p:pic>
-        <p:nvPicPr>
-          <p:cNvPr id="17412" name="Picture 17411" descr="desk-hive-detail.png"/>
-          <p:cNvPicPr>
-            <a:picLocks noChangeAspect="1"/>
-          </p:cNvPicPr>
+      <p:sp>
+        <p:nvSpPr>
+          <p:cNvPr id="17412" name="Rectangle 17411"/>
+          <p:cNvSpPr/>
           <p:nvPr/>
-        </p:nvPicPr>
-        <p:blipFill>
-          <a:blip r:embed="rId4"/>
-          <a:stretch>
-            <a:fillRect/>
-          </a:stretch>
-        </p:blipFill>
+        </p:nvSpPr>
         <p:spPr>
           <a:xfrm>
-            <a:off x="8092440" y="1188720"/>
-            <a:ext cx="3749039" cy="2343149"/>
+            <a:off x="8092440" y="1170432"/>
+            <a:ext cx="3749039" cy="274320"/>
           </a:xfrm>
           <a:prstGeom prst="rect">
             <a:avLst/>
           </a:prstGeom>
-          <a:ln w="12700">
-            <a:solidFill>
-              <a:srgbClr val="C9D4E6"/>
-            </a:solidFill>
+          <a:solidFill>
+            <a:srgbClr val="1F497D"/>
+          </a:solidFill>
+          <a:ln>
+            <a:noFill/>
           </a:ln>
+          <a:effectLst/>
         </p:spPr>
-      </p:pic>
+        <p:style>
+          <a:lnRef idx="1">
+            <a:schemeClr val="accent1"/>
+          </a:lnRef>
+          <a:fillRef idx="3">
+            <a:schemeClr val="accent1"/>
+          </a:fillRef>
+          <a:effectRef idx="2">
+            <a:schemeClr val="accent1"/>
+          </a:effectRef>
+          <a:fontRef idx="minor">
+            <a:schemeClr val="lt1"/>
+          </a:fontRef>
+        </p:style>
+        <p:txBody>
+          <a:bodyPr rtlCol="0" anchor="ctr" wrap="square" lIns="45720" rIns="45720" tIns="18288" bIns="18288"/>
+          <a:lstStyle/>
+          <a:p>
+            <a:pPr algn="l"/>
+            <a:r>
+              <a:rPr sz="1050" b="1" u="none" i="0">
+                <a:solidFill>
+                  <a:srgbClr val="FFFFFF"/>
+                </a:solidFill>
+                <a:latin typeface="Arial"/>
+              </a:rPr>
+              <a:t>How we use AI (beyond the blockchain)</a:t>
+            </a:r>
+          </a:p>
+        </p:txBody>
+      </p:sp>
       <p:sp>
         <p:nvSpPr>
           <p:cNvPr id="17413" name="TextBox 17412"/>
@@ -8331,16 +8355,18 @@
         </p:nvSpPr>
         <p:spPr>
           <a:xfrm>
-            <a:off x="8092440" y="3520440"/>
-            <a:ext cx="3749039" cy="548640"/>
+            <a:off x="8092440" y="1444752"/>
+            <a:ext cx="3749039" cy="1298448"/>
           </a:xfrm>
           <a:prstGeom prst="rect">
             <a:avLst/>
           </a:prstGeom>
-          <a:noFill/>
+          <a:solidFill>
+            <a:srgbClr val="F2F5FA"/>
+          </a:solidFill>
         </p:spPr>
         <p:txBody>
-          <a:bodyPr wrap="square" anchor="t" lIns="45720" rIns="45720" tIns="27432" bIns="27432">
+          <a:bodyPr wrap="square" anchor="t" lIns="54864" rIns="54864" tIns="27432" bIns="27432">
             <a:spAutoFit/>
           </a:bodyPr>
           <a:lstStyle/>
@@ -8357,29 +8383,324 @@
               </a:spcAft>
             </a:pPr>
             <a:r>
-              <a:rPr sz="900" b="1" u="none" i="0">
-                <a:solidFill>
-                  <a:srgbClr val="1F497D"/>
-                </a:solidFill>
-                <a:latin typeface="Arial"/>
-              </a:rPr>
-              <a:t>Working prototype – hive dashboard: </a:t>
-            </a:r>
-            <a:r>
-              <a:rPr sz="900" b="0" u="none" i="0">
-                <a:solidFill>
-                  <a:srgbClr val="595959"/>
-                </a:solidFill>
-                <a:latin typeface="Arial"/>
-              </a:rPr>
-              <a:t>AI flags "Pre-swarm 98%" with advice; live sensor tiles and 30-day yield forecast.</a:t>
-            </a:r>
-          </a:p>
-        </p:txBody>
-      </p:sp>
-      <p:sp>
-        <p:nvSpPr>
-          <p:cNvPr id="17414" name="TextBox 17413"/>
+              <a:rPr sz="860" b="1" u="none" i="0">
+                <a:solidFill>
+                  <a:srgbClr val="2E8B57"/>
+                </a:solidFill>
+                <a:latin typeface="Arial"/>
+              </a:rPr>
+              <a:t>[Built] </a:t>
+            </a:r>
+            <a:r>
+              <a:rPr sz="860" b="0" u="none" i="0">
+                <a:solidFill>
+                  <a:srgbClr val="000000"/>
+                </a:solidFill>
+                <a:latin typeface="Arial"/>
+              </a:rPr>
+              <a:t>Hive-health model: sensor features → varroa, foulbrood, queenless, pre-swarm, starvation (24/24 on simulated tests)</a:t>
+            </a:r>
+          </a:p>
+          <a:p>
+            <a:pPr algn="l">
+              <a:lnSpc>
+                <a:spcPct val="100000"/>
+              </a:lnSpc>
+              <a:spcBef>
+                <a:spcPts val="0"/>
+              </a:spcBef>
+              <a:spcAft>
+                <a:spcPts val="200"/>
+              </a:spcAft>
+            </a:pPr>
+            <a:r>
+              <a:rPr sz="860" b="1" u="none" i="0">
+                <a:solidFill>
+                  <a:srgbClr val="2E8B57"/>
+                </a:solidFill>
+                <a:latin typeface="Arial"/>
+              </a:rPr>
+              <a:t>[Built] </a:t>
+            </a:r>
+            <a:r>
+              <a:rPr sz="860" b="0" u="none" i="0">
+                <a:solidFill>
+                  <a:srgbClr val="000000"/>
+                </a:solidFill>
+                <a:latin typeface="Arial"/>
+              </a:rPr>
+              <a:t>30-day yield forecast (80% range) + fraud flag when claimed kg per hive exceeds what hive data supports</a:t>
+            </a:r>
+          </a:p>
+          <a:p>
+            <a:pPr algn="l">
+              <a:lnSpc>
+                <a:spcPct val="100000"/>
+              </a:lnSpc>
+              <a:spcBef>
+                <a:spcPts val="0"/>
+              </a:spcBef>
+              <a:spcAft>
+                <a:spcPts val="200"/>
+              </a:spcAft>
+            </a:pPr>
+            <a:r>
+              <a:rPr sz="860" b="1" u="none" i="0">
+                <a:solidFill>
+                  <a:srgbClr val="E98B1D"/>
+                </a:solidFill>
+                <a:latin typeface="Arial"/>
+              </a:rPr>
+              <a:t>[Plan] </a:t>
+            </a:r>
+            <a:r>
+              <a:rPr sz="860" b="0" u="none" i="0">
+                <a:solidFill>
+                  <a:srgbClr val="000000"/>
+                </a:solidFill>
+                <a:latin typeface="Arial"/>
+              </a:rPr>
+              <a:t>CNN on hive audio via TFLite Micro, trained on open datasets (refs 8, 9); advice shown with confidence</a:t>
+            </a:r>
+          </a:p>
+          <a:p>
+            <a:pPr algn="l">
+              <a:lnSpc>
+                <a:spcPct val="100000"/>
+              </a:lnSpc>
+              <a:spcBef>
+                <a:spcPts val="0"/>
+              </a:spcBef>
+              <a:spcAft>
+                <a:spcPts val="0"/>
+              </a:spcAft>
+            </a:pPr>
+            <a:r>
+              <a:rPr sz="860" b="1" u="none" i="0">
+                <a:solidFill>
+                  <a:srgbClr val="E98B1D"/>
+                </a:solidFill>
+                <a:latin typeface="Arial"/>
+              </a:rPr>
+              <a:t>[Plan] </a:t>
+            </a:r>
+            <a:r>
+              <a:rPr sz="860" b="0" u="none" i="0">
+                <a:solidFill>
+                  <a:srgbClr val="000000"/>
+                </a:solidFill>
+                <a:latin typeface="Arial"/>
+              </a:rPr>
+              <a:t>Comb-photo disease check on the phone; Hindi voice entry and advice for low-literacy users</a:t>
+            </a:r>
+          </a:p>
+        </p:txBody>
+      </p:sp>
+      <p:sp>
+        <p:nvSpPr>
+          <p:cNvPr id="17414" name="Rectangle 17413"/>
+          <p:cNvSpPr/>
+          <p:nvPr/>
+        </p:nvSpPr>
+        <p:spPr>
+          <a:xfrm>
+            <a:off x="8092440" y="2770632"/>
+            <a:ext cx="3749039" cy="274320"/>
+          </a:xfrm>
+          <a:prstGeom prst="rect">
+            <a:avLst/>
+          </a:prstGeom>
+          <a:solidFill>
+            <a:srgbClr val="0070C0"/>
+          </a:solidFill>
+          <a:ln>
+            <a:noFill/>
+          </a:ln>
+          <a:effectLst/>
+        </p:spPr>
+        <p:style>
+          <a:lnRef idx="1">
+            <a:schemeClr val="accent1"/>
+          </a:lnRef>
+          <a:fillRef idx="3">
+            <a:schemeClr val="accent1"/>
+          </a:fillRef>
+          <a:effectRef idx="2">
+            <a:schemeClr val="accent1"/>
+          </a:effectRef>
+          <a:fontRef idx="minor">
+            <a:schemeClr val="lt1"/>
+          </a:fontRef>
+        </p:style>
+        <p:txBody>
+          <a:bodyPr rtlCol="0" anchor="ctr" wrap="square" lIns="45720" rIns="45720" tIns="18288" bIns="18288"/>
+          <a:lstStyle/>
+          <a:p>
+            <a:pPr algn="l"/>
+            <a:r>
+              <a:rPr sz="1050" b="1" u="none" i="0">
+                <a:solidFill>
+                  <a:srgbClr val="FFFFFF"/>
+                </a:solidFill>
+                <a:latin typeface="Arial"/>
+              </a:rPr>
+              <a:t>How we use Cloud</a:t>
+            </a:r>
+          </a:p>
+        </p:txBody>
+      </p:sp>
+      <p:sp>
+        <p:nvSpPr>
+          <p:cNvPr id="17415" name="TextBox 17414"/>
+          <p:cNvSpPr txBox="1"/>
+          <p:nvPr/>
+        </p:nvSpPr>
+        <p:spPr>
+          <a:xfrm>
+            <a:off x="8092440" y="3044952"/>
+            <a:ext cx="3749039" cy="1042415"/>
+          </a:xfrm>
+          <a:prstGeom prst="rect">
+            <a:avLst/>
+          </a:prstGeom>
+          <a:solidFill>
+            <a:srgbClr val="F2F5FA"/>
+          </a:solidFill>
+        </p:spPr>
+        <p:txBody>
+          <a:bodyPr wrap="square" anchor="t" lIns="54864" rIns="54864" tIns="27432" bIns="27432">
+            <a:spAutoFit/>
+          </a:bodyPr>
+          <a:lstStyle/>
+          <a:p>
+            <a:pPr algn="l">
+              <a:lnSpc>
+                <a:spcPct val="100000"/>
+              </a:lnSpc>
+              <a:spcBef>
+                <a:spcPts val="0"/>
+              </a:spcBef>
+              <a:spcAft>
+                <a:spcPts val="200"/>
+              </a:spcAft>
+            </a:pPr>
+            <a:r>
+              <a:rPr sz="860" b="1" u="none" i="0">
+                <a:solidFill>
+                  <a:srgbClr val="2E8B57"/>
+                </a:solidFill>
+                <a:latin typeface="Arial"/>
+              </a:rPr>
+              <a:t>[Today] </a:t>
+            </a:r>
+            <a:r>
+              <a:rPr sz="860" b="0" u="none" i="0">
+                <a:solidFill>
+                  <a:srgbClr val="000000"/>
+                </a:solidFill>
+                <a:latin typeface="Arial"/>
+              </a:rPr>
+              <a:t>PWA served from a CDN (GitHub Pages / Vercel); CI/CD with GitHub Actions</a:t>
+            </a:r>
+          </a:p>
+          <a:p>
+            <a:pPr algn="l">
+              <a:lnSpc>
+                <a:spcPct val="100000"/>
+              </a:lnSpc>
+              <a:spcBef>
+                <a:spcPts val="0"/>
+              </a:spcBef>
+              <a:spcAft>
+                <a:spcPts val="200"/>
+              </a:spcAft>
+            </a:pPr>
+            <a:r>
+              <a:rPr sz="860" b="1" u="none" i="0">
+                <a:solidFill>
+                  <a:srgbClr val="E98B1D"/>
+                </a:solidFill>
+                <a:latin typeface="Arial"/>
+              </a:rPr>
+              <a:t>[Plan] </a:t>
+            </a:r>
+            <a:r>
+              <a:rPr sz="860" b="0" u="none" i="0">
+                <a:solidFill>
+                  <a:srgbClr val="000000"/>
+                </a:solidFill>
+                <a:latin typeface="Arial"/>
+              </a:rPr>
+              <a:t>LoRaWAN → MQTT broker → time-series DB; Merkle root anchored on-chain</a:t>
+            </a:r>
+          </a:p>
+          <a:p>
+            <a:pPr algn="l">
+              <a:lnSpc>
+                <a:spcPct val="100000"/>
+              </a:lnSpc>
+              <a:spcBef>
+                <a:spcPts val="0"/>
+              </a:spcBef>
+              <a:spcAft>
+                <a:spcPts val="200"/>
+              </a:spcAft>
+            </a:pPr>
+            <a:r>
+              <a:rPr sz="860" b="1" u="none" i="0">
+                <a:solidFill>
+                  <a:srgbClr val="E98B1D"/>
+                </a:solidFill>
+                <a:latin typeface="Arial"/>
+              </a:rPr>
+              <a:t>[Plan] </a:t>
+            </a:r>
+            <a:r>
+              <a:rPr sz="860" b="0" u="none" i="0">
+                <a:solidFill>
+                  <a:srgbClr val="000000"/>
+                </a:solidFill>
+                <a:latin typeface="Arial"/>
+              </a:rPr>
+              <a:t>Validator nodes + indexer as containers on MeitY-empanelled / GI Cloud; KMS/HSM keys</a:t>
+            </a:r>
+          </a:p>
+          <a:p>
+            <a:pPr algn="l">
+              <a:lnSpc>
+                <a:spcPct val="100000"/>
+              </a:lnSpc>
+              <a:spcBef>
+                <a:spcPts val="0"/>
+              </a:spcBef>
+              <a:spcAft>
+                <a:spcPts val="0"/>
+              </a:spcAft>
+            </a:pPr>
+            <a:r>
+              <a:rPr sz="860" b="1" u="none" i="0">
+                <a:solidFill>
+                  <a:srgbClr val="E98B1D"/>
+                </a:solidFill>
+                <a:latin typeface="Arial"/>
+              </a:rPr>
+              <a:t>[Plan] </a:t>
+            </a:r>
+            <a:r>
+              <a:rPr sz="860" b="0" u="none" i="0">
+                <a:solidFill>
+                  <a:srgbClr val="000000"/>
+                </a:solidFill>
+                <a:latin typeface="Arial"/>
+              </a:rPr>
+              <a:t>Cloud GPU training, OTA model updates, drift monitoring; object storage + IPFS; retailer API; SMS / WhatsApp alerts</a:t>
+            </a:r>
+          </a:p>
+        </p:txBody>
+      </p:sp>
+      <p:sp>
+        <p:nvSpPr>
+          <p:cNvPr id="17416" name="TextBox 17415"/>
           <p:cNvSpPr txBox="1"/>
           <p:nvPr/>
         </p:nvSpPr>
@@ -8433,7 +8754,7 @@
       </p:sp>
       <p:sp>
         <p:nvSpPr>
-          <p:cNvPr id="17415" name="Pentagon 17414"/>
+          <p:cNvPr id="17417" name="Pentagon 17416"/>
           <p:cNvSpPr/>
           <p:nvPr/>
         </p:nvSpPr>
@@ -8486,7 +8807,7 @@
       </p:sp>
       <p:sp>
         <p:nvSpPr>
-          <p:cNvPr id="17416" name="TextBox 17415"/>
+          <p:cNvPr id="17418" name="TextBox 17417"/>
           <p:cNvSpPr txBox="1"/>
           <p:nvPr/>
         </p:nvSpPr>
@@ -8563,7 +8884,7 @@
       </p:sp>
       <p:sp>
         <p:nvSpPr>
-          <p:cNvPr id="17417" name="Pentagon 17416"/>
+          <p:cNvPr id="17419" name="Pentagon 17418"/>
           <p:cNvSpPr/>
           <p:nvPr/>
         </p:nvSpPr>
@@ -8616,7 +8937,7 @@
       </p:sp>
       <p:sp>
         <p:nvSpPr>
-          <p:cNvPr id="17418" name="TextBox 17417"/>
+          <p:cNvPr id="17420" name="TextBox 17419"/>
           <p:cNvSpPr txBox="1"/>
           <p:nvPr/>
         </p:nvSpPr>
@@ -8719,7 +9040,7 @@
       </p:sp>
       <p:sp>
         <p:nvSpPr>
-          <p:cNvPr id="17419" name="Pentagon 17418"/>
+          <p:cNvPr id="17421" name="Pentagon 17420"/>
           <p:cNvSpPr/>
           <p:nvPr/>
         </p:nvSpPr>
@@ -8772,7 +9093,7 @@
       </p:sp>
       <p:sp>
         <p:nvSpPr>
-          <p:cNvPr id="17420" name="TextBox 17419"/>
+          <p:cNvPr id="17422" name="TextBox 17421"/>
           <p:cNvSpPr txBox="1"/>
           <p:nvPr/>
         </p:nvSpPr>
@@ -8875,7 +9196,7 @@
       </p:sp>
       <p:sp>
         <p:nvSpPr>
-          <p:cNvPr id="17421" name="Pentagon 17420"/>
+          <p:cNvPr id="17423" name="Pentagon 17422"/>
           <p:cNvSpPr/>
           <p:nvPr/>
         </p:nvSpPr>
@@ -8928,7 +9249,7 @@
       </p:sp>
       <p:sp>
         <p:nvSpPr>
-          <p:cNvPr id="17422" name="TextBox 17421"/>
+          <p:cNvPr id="17424" name="TextBox 17423"/>
           <p:cNvSpPr txBox="1"/>
           <p:nvPr/>
         </p:nvSpPr>
@@ -9031,7 +9352,7 @@
       </p:sp>
       <p:sp>
         <p:nvSpPr>
-          <p:cNvPr id="17423" name="Pentagon 17422"/>
+          <p:cNvPr id="17425" name="Pentagon 17424"/>
           <p:cNvSpPr/>
           <p:nvPr/>
         </p:nvSpPr>
@@ -9084,7 +9405,7 @@
       </p:sp>
       <p:sp>
         <p:nvSpPr>
-          <p:cNvPr id="17424" name="TextBox 17423"/>
+          <p:cNvPr id="17426" name="TextBox 17425"/>
           <p:cNvSpPr txBox="1"/>
           <p:nvPr/>
         </p:nvSpPr>
@@ -9187,7 +9508,7 @@
       </p:sp>
       <p:sp>
         <p:nvSpPr>
-          <p:cNvPr id="17425" name="Pentagon 17424"/>
+          <p:cNvPr id="17427" name="Pentagon 17426"/>
           <p:cNvSpPr/>
           <p:nvPr/>
         </p:nvSpPr>
@@ -9240,7 +9561,7 @@
       </p:sp>
       <p:sp>
         <p:nvSpPr>
-          <p:cNvPr id="17426" name="TextBox 17425"/>
+          <p:cNvPr id="17428" name="TextBox 17427"/>
           <p:cNvSpPr txBox="1"/>
           <p:nvPr/>
         </p:nvSpPr>
@@ -9343,7 +9664,7 @@
       </p:sp>
       <p:sp>
         <p:nvSpPr>
-          <p:cNvPr id="17427" name="TextBox 17426"/>
+          <p:cNvPr id="17429" name="TextBox 17428"/>
           <p:cNvSpPr txBox="1"/>
           <p:nvPr/>
         </p:nvSpPr>

</xml_diff>

<commit_message>
Realistic receipt printing, deck QR codes for live app and source
- Printing: irregular line-feed bursts with pauses, paper vibration, glowing
  thermal-head heat line at the slot, overshoot-and-settle swing; sound follows
  the same schedule (motor whir, feed ratchet, head buzz, final clunk)
- Deck slide 6: QR codes for the live app (Vercel) and source code (GitHub),
  verified by decoding from the rendered slide; sample-batch QR points to the
  live app; QR images stored in docs/assets
- README: live demo link; print-animation measurement tool

Co-Authored-By: Claude Sonnet 5.5 <noreply@anthropic.com>
</commit_message>
<xml_diff>
--- a/docs/SIH2026-Idea-Presentation.pptx
+++ b/docs/SIH2026-Idea-Presentation.pptx
@@ -15805,7 +15805,7 @@
       </p:sp>
       <p:pic>
         <p:nvPicPr>
-          <p:cNvPr id="17419" name="Picture 17418" descr="qr-demo.png"/>
+          <p:cNvPr id="17419" name="Picture 17418" descr="qr-live.png"/>
           <p:cNvPicPr>
             <a:picLocks noChangeAspect="1"/>
           </p:cNvPicPr>
@@ -15819,8 +15819,8 @@
         </p:blipFill>
         <p:spPr>
           <a:xfrm>
-            <a:off x="7635240" y="5394960"/>
-            <a:ext cx="694944" cy="694944"/>
+            <a:off x="7589520" y="5376672"/>
+            <a:ext cx="713232" cy="713232"/>
           </a:xfrm>
           <a:prstGeom prst="rect">
             <a:avLst/>
@@ -15829,7 +15829,7 @@
       </p:pic>
       <p:pic>
         <p:nvPicPr>
-          <p:cNvPr id="17420" name="Picture 17419" descr="qr-repo.png"/>
+          <p:cNvPr id="17420" name="Picture 17419" descr="qr-source.png"/>
           <p:cNvPicPr>
             <a:picLocks noChangeAspect="1"/>
           </p:cNvPicPr>
@@ -15843,8 +15843,8 @@
         </p:blipFill>
         <p:spPr>
           <a:xfrm>
-            <a:off x="9098280" y="5394960"/>
-            <a:ext cx="694944" cy="694944"/>
+            <a:off x="9070848" y="5376672"/>
+            <a:ext cx="713232" cy="713232"/>
           </a:xfrm>
           <a:prstGeom prst="rect">
             <a:avLst/>
@@ -15867,8 +15867,8 @@
         </p:blipFill>
         <p:spPr>
           <a:xfrm>
-            <a:off x="10561320" y="5394960"/>
-            <a:ext cx="694944" cy="694944"/>
+            <a:off x="10552176" y="5376672"/>
+            <a:ext cx="713232" cy="713232"/>
           </a:xfrm>
           <a:prstGeom prst="rect">
             <a:avLst/>
@@ -15883,8 +15883,8 @@
         </p:nvSpPr>
         <p:spPr>
           <a:xfrm>
-            <a:off x="7360920" y="6126480"/>
-            <a:ext cx="1463040" cy="201168"/>
+            <a:off x="7388352" y="6053328"/>
+            <a:ext cx="1481328" cy="292608"/>
           </a:xfrm>
           <a:prstGeom prst="rect">
             <a:avLst/>
@@ -15892,7 +15892,7 @@
           <a:noFill/>
         </p:spPr>
         <p:txBody>
-          <a:bodyPr wrap="square" anchor="t" lIns="45720" rIns="45720" tIns="27432" bIns="27432">
+          <a:bodyPr wrap="square" anchor="t" lIns="0" rIns="0" tIns="27432" bIns="27432">
             <a:spAutoFit/>
           </a:bodyPr>
           <a:lstStyle/>
@@ -15905,17 +15905,39 @@
                 <a:spcPts val="0"/>
               </a:spcBef>
               <a:spcAft>
+                <a:spcPts val="0"/>
+              </a:spcAft>
+            </a:pPr>
+            <a:r>
+              <a:rPr sz="850" b="1" u="none" i="0">
+                <a:solidFill>
+                  <a:srgbClr val="000000"/>
+                </a:solidFill>
+                <a:latin typeface="Arial"/>
+              </a:rPr>
+              <a:t>Live app</a:t>
+            </a:r>
+          </a:p>
+          <a:p>
+            <a:pPr algn="ctr">
+              <a:lnSpc>
+                <a:spcPct val="100000"/>
+              </a:lnSpc>
+              <a:spcBef>
+                <a:spcPts val="0"/>
+              </a:spcBef>
+              <a:spcAft>
                 <a:spcPts val="200"/>
               </a:spcAft>
             </a:pPr>
             <a:r>
-              <a:rPr sz="850" b="1" u="none" i="0">
-                <a:solidFill>
-                  <a:srgbClr val="000000"/>
-                </a:solidFill>
-                <a:latin typeface="Arial"/>
-              </a:rPr>
-              <a:t>Live demo</a:t>
+              <a:rPr sz="650" b="0" u="none" i="0">
+                <a:solidFill>
+                  <a:srgbClr val="0070C0"/>
+                </a:solidFill>
+                <a:latin typeface="Arial"/>
+              </a:rPr>
+              <a:t>honey-chain-rust.vercel.app</a:t>
             </a:r>
           </a:p>
         </p:txBody>
@@ -15928,8 +15950,8 @@
         </p:nvSpPr>
         <p:spPr>
           <a:xfrm>
-            <a:off x="8823960" y="6126480"/>
-            <a:ext cx="1463040" cy="201168"/>
+            <a:off x="8869680" y="6053328"/>
+            <a:ext cx="1481328" cy="292608"/>
           </a:xfrm>
           <a:prstGeom prst="rect">
             <a:avLst/>
@@ -15937,7 +15959,7 @@
           <a:noFill/>
         </p:spPr>
         <p:txBody>
-          <a:bodyPr wrap="square" anchor="t" lIns="45720" rIns="45720" tIns="27432" bIns="27432">
+          <a:bodyPr wrap="square" anchor="t" lIns="0" rIns="0" tIns="27432" bIns="27432">
             <a:spAutoFit/>
           </a:bodyPr>
           <a:lstStyle/>
@@ -15950,17 +15972,39 @@
                 <a:spcPts val="0"/>
               </a:spcBef>
               <a:spcAft>
+                <a:spcPts val="0"/>
+              </a:spcAft>
+            </a:pPr>
+            <a:r>
+              <a:rPr sz="850" b="1" u="none" i="0">
+                <a:solidFill>
+                  <a:srgbClr val="000000"/>
+                </a:solidFill>
+                <a:latin typeface="Arial"/>
+              </a:rPr>
+              <a:t>Source code</a:t>
+            </a:r>
+          </a:p>
+          <a:p>
+            <a:pPr algn="ctr">
+              <a:lnSpc>
+                <a:spcPct val="100000"/>
+              </a:lnSpc>
+              <a:spcBef>
+                <a:spcPts val="0"/>
+              </a:spcBef>
+              <a:spcAft>
                 <a:spcPts val="200"/>
               </a:spcAft>
             </a:pPr>
             <a:r>
-              <a:rPr sz="850" b="1" u="none" i="0">
-                <a:solidFill>
-                  <a:srgbClr val="000000"/>
-                </a:solidFill>
-                <a:latin typeface="Arial"/>
-              </a:rPr>
-              <a:t>Source code</a:t>
+              <a:rPr sz="650" b="0" u="none" i="0">
+                <a:solidFill>
+                  <a:srgbClr val="0070C0"/>
+                </a:solidFill>
+                <a:latin typeface="Arial"/>
+              </a:rPr>
+              <a:t>github.com/Suyash2527/HoneyChain</a:t>
             </a:r>
           </a:p>
         </p:txBody>
@@ -15973,8 +16017,8 @@
         </p:nvSpPr>
         <p:spPr>
           <a:xfrm>
-            <a:off x="10287000" y="6126480"/>
-            <a:ext cx="1463040" cy="201168"/>
+            <a:off x="10351008" y="6053328"/>
+            <a:ext cx="1481328" cy="292608"/>
           </a:xfrm>
           <a:prstGeom prst="rect">
             <a:avLst/>
@@ -15982,7 +16026,7 @@
           <a:noFill/>
         </p:spPr>
         <p:txBody>
-          <a:bodyPr wrap="square" anchor="t" lIns="45720" rIns="45720" tIns="27432" bIns="27432">
+          <a:bodyPr wrap="square" anchor="t" lIns="0" rIns="0" tIns="27432" bIns="27432">
             <a:spAutoFit/>
           </a:bodyPr>
           <a:lstStyle/>
@@ -15995,62 +16039,39 @@
                 <a:spcPts val="0"/>
               </a:spcBef>
               <a:spcAft>
+                <a:spcPts val="0"/>
+              </a:spcAft>
+            </a:pPr>
+            <a:r>
+              <a:rPr sz="850" b="1" u="none" i="0">
+                <a:solidFill>
+                  <a:srgbClr val="000000"/>
+                </a:solidFill>
+                <a:latin typeface="Arial"/>
+              </a:rPr>
+              <a:t>Verify a sample batch</a:t>
+            </a:r>
+          </a:p>
+          <a:p>
+            <a:pPr algn="ctr">
+              <a:lnSpc>
+                <a:spcPct val="100000"/>
+              </a:lnSpc>
+              <a:spcBef>
+                <a:spcPts val="0"/>
+              </a:spcBef>
+              <a:spcAft>
                 <a:spcPts val="200"/>
               </a:spcAft>
             </a:pPr>
             <a:r>
-              <a:rPr sz="850" b="1" u="none" i="0">
-                <a:solidFill>
-                  <a:srgbClr val="000000"/>
-                </a:solidFill>
-                <a:latin typeface="Arial"/>
-              </a:rPr>
-              <a:t>Verify sample</a:t>
-            </a:r>
-          </a:p>
-        </p:txBody>
-      </p:sp>
-      <p:sp>
-        <p:nvSpPr>
-          <p:cNvPr id="17425" name="TextBox 17424"/>
-          <p:cNvSpPr txBox="1"/>
-          <p:nvPr/>
-        </p:nvSpPr>
-        <p:spPr>
-          <a:xfrm>
-            <a:off x="1234440" y="6400800"/>
-            <a:ext cx="91440" cy="91440"/>
-          </a:xfrm>
-          <a:prstGeom prst="rect">
-            <a:avLst/>
-          </a:prstGeom>
-          <a:noFill/>
-        </p:spPr>
-        <p:txBody>
-          <a:bodyPr wrap="square" anchor="t" lIns="45720" rIns="45720" tIns="27432" bIns="27432">
-            <a:spAutoFit/>
-          </a:bodyPr>
-          <a:lstStyle/>
-          <a:p>
-            <a:pPr algn="l">
-              <a:lnSpc>
-                <a:spcPct val="100000"/>
-              </a:lnSpc>
-              <a:spcBef>
-                <a:spcPts val="0"/>
-              </a:spcBef>
-              <a:spcAft>
-                <a:spcPts val="200"/>
-              </a:spcAft>
-            </a:pPr>
-            <a:r>
-              <a:rPr sz="100" b="0" u="none" i="0">
-                <a:solidFill>
-                  <a:srgbClr val="000000"/>
-                </a:solidFill>
-                <a:latin typeface="Arial"/>
-              </a:rPr>
-              <a:t/>
+              <a:rPr sz="650" b="0" u="none" i="0">
+                <a:solidFill>
+                  <a:srgbClr val="0070C0"/>
+                </a:solidFill>
+                <a:latin typeface="Arial"/>
+              </a:rPr>
+              <a:t>live app, batch HC-2026-0001</a:t>
             </a:r>
           </a:p>
         </p:txBody>

</xml_diff>

<commit_message>
SIH deck: demo video and live prototype links on the title slide, video QR on slide 6
All links are clickable in the PDF; every QR verified to scan from the rendered PDF.

Co-Authored-By: Claude Opus 5.5 <noreply@anthropic.com>
</commit_message>
<xml_diff>
--- a/docs/SIH2026-Idea-Presentation.pptx
+++ b/docs/SIH2026-Idea-Presentation.pptx
@@ -5820,6 +5820,72 @@
               <a:cs typeface="Arial" panose="020B0604020202020204" pitchFamily="34" charset="0"/>
             </a:endParaRPr>
           </a:p>
+          <a:p>
+            <a:pPr marL="285750" indent="-285750" algn="l">
+              <a:lnSpc>
+                <a:spcPct val="100000"/>
+              </a:lnSpc>
+              <a:spcAft>
+                <a:spcPts val="500"/>
+              </a:spcAft>
+              <a:buFont typeface="Arial" panose="020B0604020202020204" pitchFamily="34" charset="0"/>
+              <a:buChar char="•"/>
+            </a:pPr>
+            <a:r>
+              <a:rPr lang="en-US" sz="1700" b="1" dirty="0">
+                <a:latin typeface="Arial" panose="020B0604020202020204" pitchFamily="34" charset="0"/>
+                <a:cs typeface="Arial" panose="020B0604020202020204" pitchFamily="34" charset="0"/>
+              </a:rPr>
+              <a:t>Live Prototype- </a:t>
+            </a:r>
+            <a:r>
+              <a:rPr b="1" sz="1700">
+                <a:solidFill>
+                  <a:srgbClr val="1F497D"/>
+                </a:solidFill>
+                <a:latin typeface="Arial"/>
+                <a:hlinkClick r:id="rId4"/>
+              </a:rPr>
+              <a:t>honey-chain-rust.vercel.app</a:t>
+            </a:r>
+            <a:endParaRPr lang="en-IN" sz="2400" b="1" dirty="0">
+              <a:latin typeface="Arial" panose="020B0604020202020204" pitchFamily="34" charset="0"/>
+              <a:cs typeface="Arial" panose="020B0604020202020204" pitchFamily="34" charset="0"/>
+            </a:endParaRPr>
+          </a:p>
+          <a:p>
+            <a:pPr marL="285750" indent="-285750" algn="l">
+              <a:lnSpc>
+                <a:spcPct val="100000"/>
+              </a:lnSpc>
+              <a:spcAft>
+                <a:spcPts val="500"/>
+              </a:spcAft>
+              <a:buFont typeface="Arial" panose="020B0604020202020204" pitchFamily="34" charset="0"/>
+              <a:buChar char="•"/>
+            </a:pPr>
+            <a:r>
+              <a:rPr lang="en-US" sz="1700" b="1" dirty="0">
+                <a:latin typeface="Arial" panose="020B0604020202020204" pitchFamily="34" charset="0"/>
+                <a:cs typeface="Arial" panose="020B0604020202020204" pitchFamily="34" charset="0"/>
+              </a:rPr>
+              <a:t>Demo Video- </a:t>
+            </a:r>
+            <a:r>
+              <a:rPr b="1" sz="1700">
+                <a:solidFill>
+                  <a:srgbClr val="1F497D"/>
+                </a:solidFill>
+                <a:latin typeface="Arial"/>
+                <a:hlinkClick r:id="rId5"/>
+              </a:rPr>
+              <a:t>youtu.be/-nWbjNHHzBw</a:t>
+            </a:r>
+            <a:endParaRPr lang="en-IN" sz="2400" b="1" dirty="0">
+              <a:latin typeface="Arial" panose="020B0604020202020204" pitchFamily="34" charset="0"/>
+              <a:cs typeface="Arial" panose="020B0604020202020204" pitchFamily="34" charset="0"/>
+            </a:endParaRPr>
+          </a:p>
         </p:txBody>
       </p:sp>
       <p:pic>
@@ -15798,14 +15864,16 @@
                 </a:solidFill>
                 <a:latin typeface="Arial"/>
               </a:rPr>
-              <a:t>TRY THE PROTOTYPE</a:t>
+              <a:t>TRY THE PROTOTYPE  ·  WATCH THE DEMO</a:t>
             </a:r>
           </a:p>
         </p:txBody>
       </p:sp>
       <p:pic>
         <p:nvPicPr>
-          <p:cNvPr id="17419" name="Picture 17418" descr="qr-live.png"/>
+          <p:cNvPr id="17419" name="Picture 17418" descr="qr-video.png">
+            <a:hlinkClick r:id="rId5"/>
+          </p:cNvPr>
           <p:cNvPicPr>
             <a:picLocks noChangeAspect="1"/>
           </p:cNvPicPr>
@@ -15819,41 +15887,88 @@
         </p:blipFill>
         <p:spPr>
           <a:xfrm>
-            <a:off x="7589520" y="5376672"/>
-            <a:ext cx="713232" cy="713232"/>
+            <a:off x="7612379" y="5394960"/>
+            <a:ext cx="658368" cy="658368"/>
           </a:xfrm>
           <a:prstGeom prst="rect">
             <a:avLst/>
           </a:prstGeom>
         </p:spPr>
       </p:pic>
-      <p:pic>
-        <p:nvPicPr>
-          <p:cNvPr id="17420" name="Picture 17419" descr="qr-source.png"/>
-          <p:cNvPicPr>
-            <a:picLocks noChangeAspect="1"/>
-          </p:cNvPicPr>
+      <p:sp>
+        <p:nvSpPr>
+          <p:cNvPr id="17420" name="TextBox 17419"/>
+          <p:cNvSpPr txBox="1"/>
           <p:nvPr/>
-        </p:nvPicPr>
-        <p:blipFill>
-          <a:blip r:embed="rId5"/>
-          <a:stretch>
-            <a:fillRect/>
-          </a:stretch>
-        </p:blipFill>
+        </p:nvSpPr>
         <p:spPr>
           <a:xfrm>
-            <a:off x="9070848" y="5376672"/>
-            <a:ext cx="713232" cy="713232"/>
+            <a:off x="7388352" y="6053328"/>
+            <a:ext cx="1106424" cy="292608"/>
           </a:xfrm>
           <a:prstGeom prst="rect">
             <a:avLst/>
           </a:prstGeom>
+          <a:noFill/>
         </p:spPr>
-      </p:pic>
+        <p:txBody>
+          <a:bodyPr wrap="square" anchor="t" lIns="0" rIns="0" tIns="27432" bIns="27432">
+            <a:spAutoFit/>
+          </a:bodyPr>
+          <a:lstStyle/>
+          <a:p>
+            <a:pPr algn="ctr">
+              <a:lnSpc>
+                <a:spcPct val="100000"/>
+              </a:lnSpc>
+              <a:spcBef>
+                <a:spcPts val="0"/>
+              </a:spcBef>
+              <a:spcAft>
+                <a:spcPts val="0"/>
+              </a:spcAft>
+            </a:pPr>
+            <a:r>
+              <a:rPr sz="800" b="1" u="none" i="0">
+                <a:solidFill>
+                  <a:srgbClr val="B3372F"/>
+                </a:solidFill>
+                <a:latin typeface="Arial"/>
+                <a:hlinkClick r:id="rId5"/>
+              </a:rPr>
+              <a:t>Demo video (3 min)</a:t>
+            </a:r>
+          </a:p>
+          <a:p>
+            <a:pPr algn="ctr">
+              <a:lnSpc>
+                <a:spcPct val="100000"/>
+              </a:lnSpc>
+              <a:spcBef>
+                <a:spcPts val="0"/>
+              </a:spcBef>
+              <a:spcAft>
+                <a:spcPts val="200"/>
+              </a:spcAft>
+            </a:pPr>
+            <a:r>
+              <a:rPr sz="600" b="0" u="none" i="0">
+                <a:solidFill>
+                  <a:srgbClr val="0070C0"/>
+                </a:solidFill>
+                <a:latin typeface="Arial"/>
+                <a:hlinkClick r:id="rId5"/>
+              </a:rPr>
+              <a:t>youtu.be/-nWbjNHHzBw</a:t>
+            </a:r>
+          </a:p>
+        </p:txBody>
+      </p:sp>
       <p:pic>
         <p:nvPicPr>
-          <p:cNvPr id="17421" name="Picture 17420" descr="qr-verify.png"/>
+          <p:cNvPr id="17421" name="Picture 17420" descr="qr-live.png">
+            <a:hlinkClick r:id="rId7"/>
+          </p:cNvPr>
           <p:cNvPicPr>
             <a:picLocks noChangeAspect="1"/>
           </p:cNvPicPr>
@@ -15867,8 +15982,8 @@
         </p:blipFill>
         <p:spPr>
           <a:xfrm>
-            <a:off x="10552176" y="5376672"/>
-            <a:ext cx="713232" cy="713232"/>
+            <a:off x="8718803" y="5394960"/>
+            <a:ext cx="658368" cy="658368"/>
           </a:xfrm>
           <a:prstGeom prst="rect">
             <a:avLst/>
@@ -15883,8 +15998,8 @@
         </p:nvSpPr>
         <p:spPr>
           <a:xfrm>
-            <a:off x="7388352" y="6053328"/>
-            <a:ext cx="1481328" cy="292608"/>
+            <a:off x="8494776" y="6053328"/>
+            <a:ext cx="1106424" cy="292608"/>
           </a:xfrm>
           <a:prstGeom prst="rect">
             <a:avLst/>
@@ -15909,11 +16024,12 @@
               </a:spcAft>
             </a:pPr>
             <a:r>
-              <a:rPr sz="850" b="1" u="none" i="0">
+              <a:rPr sz="800" b="1" u="none" i="0">
                 <a:solidFill>
                   <a:srgbClr val="000000"/>
                 </a:solidFill>
                 <a:latin typeface="Arial"/>
+                <a:hlinkClick r:id="rId7"/>
               </a:rPr>
               <a:t>Live app</a:t>
             </a:r>
@@ -15931,27 +16047,54 @@
               </a:spcAft>
             </a:pPr>
             <a:r>
-              <a:rPr sz="650" b="0" u="none" i="0">
+              <a:rPr sz="600" b="0" u="none" i="0">
                 <a:solidFill>
                   <a:srgbClr val="0070C0"/>
                 </a:solidFill>
                 <a:latin typeface="Arial"/>
+                <a:hlinkClick r:id="rId7"/>
               </a:rPr>
               <a:t>honey-chain-rust.vercel.app</a:t>
             </a:r>
           </a:p>
         </p:txBody>
       </p:sp>
-      <p:sp>
-        <p:nvSpPr>
-          <p:cNvPr id="17423" name="TextBox 17422"/>
+      <p:pic>
+        <p:nvPicPr>
+          <p:cNvPr id="17423" name="Picture 17422" descr="qr-source.png">
+            <a:hlinkClick r:id="rId9"/>
+          </p:cNvPr>
+          <p:cNvPicPr>
+            <a:picLocks noChangeAspect="1"/>
+          </p:cNvPicPr>
+          <p:nvPr/>
+        </p:nvPicPr>
+        <p:blipFill>
+          <a:blip r:embed="rId8"/>
+          <a:stretch>
+            <a:fillRect/>
+          </a:stretch>
+        </p:blipFill>
+        <p:spPr>
+          <a:xfrm>
+            <a:off x="9825228" y="5394960"/>
+            <a:ext cx="658368" cy="658368"/>
+          </a:xfrm>
+          <a:prstGeom prst="rect">
+            <a:avLst/>
+          </a:prstGeom>
+        </p:spPr>
+      </p:pic>
+      <p:sp>
+        <p:nvSpPr>
+          <p:cNvPr id="17424" name="TextBox 17423"/>
           <p:cNvSpPr txBox="1"/>
           <p:nvPr/>
         </p:nvSpPr>
         <p:spPr>
           <a:xfrm>
-            <a:off x="8869680" y="6053328"/>
-            <a:ext cx="1481328" cy="292608"/>
+            <a:off x="9601200" y="6053328"/>
+            <a:ext cx="1106424" cy="292608"/>
           </a:xfrm>
           <a:prstGeom prst="rect">
             <a:avLst/>
@@ -15976,11 +16119,12 @@
               </a:spcAft>
             </a:pPr>
             <a:r>
-              <a:rPr sz="850" b="1" u="none" i="0">
+              <a:rPr sz="800" b="1" u="none" i="0">
                 <a:solidFill>
                   <a:srgbClr val="000000"/>
                 </a:solidFill>
                 <a:latin typeface="Arial"/>
+                <a:hlinkClick r:id="rId9"/>
               </a:rPr>
               <a:t>Source code</a:t>
             </a:r>
@@ -15998,27 +16142,54 @@
               </a:spcAft>
             </a:pPr>
             <a:r>
-              <a:rPr sz="650" b="0" u="none" i="0">
+              <a:rPr sz="600" b="0" u="none" i="0">
                 <a:solidFill>
                   <a:srgbClr val="0070C0"/>
                 </a:solidFill>
                 <a:latin typeface="Arial"/>
-              </a:rPr>
-              <a:t>github.com/Suyash2527/HoneyChain</a:t>
-            </a:r>
-          </a:p>
-        </p:txBody>
-      </p:sp>
-      <p:sp>
-        <p:nvSpPr>
-          <p:cNvPr id="17424" name="TextBox 17423"/>
+                <a:hlinkClick r:id="rId9"/>
+              </a:rPr>
+              <a:t>Suyash2527/HoneyChain</a:t>
+            </a:r>
+          </a:p>
+        </p:txBody>
+      </p:sp>
+      <p:pic>
+        <p:nvPicPr>
+          <p:cNvPr id="17425" name="Picture 17424" descr="qr-verify.png">
+            <a:hlinkClick r:id="rId11"/>
+          </p:cNvPr>
+          <p:cNvPicPr>
+            <a:picLocks noChangeAspect="1"/>
+          </p:cNvPicPr>
+          <p:nvPr/>
+        </p:nvPicPr>
+        <p:blipFill>
+          <a:blip r:embed="rId10"/>
+          <a:stretch>
+            <a:fillRect/>
+          </a:stretch>
+        </p:blipFill>
+        <p:spPr>
+          <a:xfrm>
+            <a:off x="10931652" y="5394960"/>
+            <a:ext cx="658368" cy="658368"/>
+          </a:xfrm>
+          <a:prstGeom prst="rect">
+            <a:avLst/>
+          </a:prstGeom>
+        </p:spPr>
+      </p:pic>
+      <p:sp>
+        <p:nvSpPr>
+          <p:cNvPr id="17426" name="TextBox 17425"/>
           <p:cNvSpPr txBox="1"/>
           <p:nvPr/>
         </p:nvSpPr>
         <p:spPr>
           <a:xfrm>
-            <a:off x="10351008" y="6053328"/>
-            <a:ext cx="1481328" cy="292608"/>
+            <a:off x="10707624" y="6053328"/>
+            <a:ext cx="1106424" cy="292608"/>
           </a:xfrm>
           <a:prstGeom prst="rect">
             <a:avLst/>
@@ -16043,13 +16214,14 @@
               </a:spcAft>
             </a:pPr>
             <a:r>
-              <a:rPr sz="850" b="1" u="none" i="0">
+              <a:rPr sz="800" b="1" u="none" i="0">
                 <a:solidFill>
                   <a:srgbClr val="000000"/>
                 </a:solidFill>
                 <a:latin typeface="Arial"/>
-              </a:rPr>
-              <a:t>Verify a sample batch</a:t>
+                <a:hlinkClick r:id="rId11"/>
+              </a:rPr>
+              <a:t>Verify a sample</a:t>
             </a:r>
           </a:p>
           <a:p>
@@ -16065,13 +16237,14 @@
               </a:spcAft>
             </a:pPr>
             <a:r>
-              <a:rPr sz="650" b="0" u="none" i="0">
+              <a:rPr sz="600" b="0" u="none" i="0">
                 <a:solidFill>
                   <a:srgbClr val="0070C0"/>
                 </a:solidFill>
                 <a:latin typeface="Arial"/>
-              </a:rPr>
-              <a:t>live app, batch HC-2026-0008</a:t>
+                <a:hlinkClick r:id="rId11"/>
+              </a:rPr>
+              <a:t>batch HC-2026-0008</a:t>
             </a:r>
           </a:p>
         </p:txBody>

</xml_diff>

<commit_message>
SIH deck: team name CodeVerse9, exactly as registered on the portal
Co-Authored-By: Claude Opus 5.5 <noreply@anthropic.com>
</commit_message>
<xml_diff>
--- a/docs/SIH2026-Idea-Presentation.pptx
+++ b/docs/SIH2026-Idea-Presentation.pptx
@@ -5813,7 +5813,7 @@
                 </a:solidFill>
                 <a:latin typeface="Arial"/>
               </a:rPr>
-              <a:t>CodeVerse</a:t>
+              <a:t>CodeVerse9</a:t>
             </a:r>
             <a:endParaRPr lang="en-IN" sz="2400" b="1" dirty="0">
               <a:latin typeface="Arial" panose="020B0604020202020204" pitchFamily="34" charset="0"/>
@@ -6164,7 +6164,7 @@
             <a:pPr algn="ctr"/>
             <a:r>
               <a:rPr lang="en-US" dirty="0" sz="1100"/>
-              <a:t>CodeVerse</a:t>
+              <a:t>CodeVerse9</a:t>
             </a:r>
             <a:endParaRPr lang="en-IN" dirty="0"/>
           </a:p>
@@ -7699,7 +7699,7 @@
             <a:pPr algn="ctr"/>
             <a:r>
               <a:rPr lang="en-US" dirty="0" sz="1100"/>
-              <a:t>CodeVerse</a:t>
+              <a:t>CodeVerse9</a:t>
             </a:r>
             <a:endParaRPr lang="en-IN" dirty="0"/>
           </a:p>
@@ -10148,7 +10148,7 @@
             <a:pPr algn="ctr"/>
             <a:r>
               <a:rPr lang="en-US" dirty="0" sz="1100"/>
-              <a:t>CodeVerse</a:t>
+              <a:t>CodeVerse9</a:t>
             </a:r>
             <a:endParaRPr lang="en-IN" dirty="0"/>
           </a:p>
@@ -12331,7 +12331,7 @@
             <a:pPr algn="ctr"/>
             <a:r>
               <a:rPr lang="en-US" dirty="0" sz="1100"/>
-              <a:t>CodeVerse</a:t>
+              <a:t>CodeVerse9</a:t>
             </a:r>
             <a:endParaRPr lang="en-IN" dirty="0"/>
           </a:p>
@@ -14646,7 +14646,7 @@
             <a:pPr algn="ctr"/>
             <a:r>
               <a:rPr lang="en-US" dirty="0" sz="1100"/>
-              <a:t>CodeVerse</a:t>
+              <a:t>CodeVerse9</a:t>
             </a:r>
             <a:endParaRPr lang="en-IN" dirty="0"/>
           </a:p>

</xml_diff>